<commit_message>
feat: generate all ECMA-376 preset geometries from presetShapeDefinitions.xml
- scripts/gen_preset_geom.py converts presetShapeDefinitions.xml into
  renderer_geom_presets.mbt (182 presets + non-standard aliases); the
  hand-written table (~140 approximations, 39 presets missing) is gone
- per-path a:path fill / stroke: fill="none" sub-paths are stroke-only,
  stroke="false" ones fill-only, darken/lighten modes shade the fill with a
  black/white overlay; stroke-only sub-paths are drawn after the fills
  (chartPlus/chartX/chartStar); a plain preset is still one <path>
- preset text rectangles come from each preset's a:rect; the hand-written
  get_preset_text_rect / add_text_rect_guides are removed

Tests: renderer_geom_wbtest (styles, shading, draw order, text rects),
fixture slide 101 + regressions.test.mjs.

Co-Authored-By: Claude Opus 5.5 <noreply@anthropic.com>
</commit_message>
<xml_diff>
--- a/test_fixtures/test_features.pptx
+++ b/test_fixtures/test_features.pptx
@@ -105,6 +105,7 @@
     <p:sldId id="353" r:id="rId106"/>
     <p:sldId id="354" r:id="rId107"/>
     <p:sldId id="355" r:id="rId108"/>
+    <p:sldId id="356" r:id="rId109"/>
   </p:sldIdLst>
   <p:sldSz cx="9144000" cy="6858000" type="screen4x3"/>
   <p:notesSz cx="6858000" cy="9144000"/>
@@ -8774,6 +8775,168 @@
           <a:solidFill>
             <a:srgbClr val="5B9BD5"/>
           </a:solidFill>
+        </p:spPr>
+      </p:sp>
+    </p:spTree>
+  </p:cSld>
+  <p:clrMapOvr>
+    <a:masterClrMapping/>
+  </p:clrMapOvr>
+</p:sld>
+</file>
+
+<file path=ppt/slides/slide101.xml><?xml version="1.0" encoding="utf-8"?>
+<p:sld xmlns:a="http://schemas.openxmlformats.org/drawingml/2006/main" xmlns:p="http://schemas.openxmlformats.org/presentationml/2006/main" xmlns:r="http://schemas.openxmlformats.org/officeDocument/2006/relationships">
+  <p:cSld>
+    <p:spTree>
+      <p:nvGrpSpPr>
+        <p:cNvPr id="1" name=""/>
+        <p:cNvGrpSpPr/>
+        <p:nvPr/>
+      </p:nvGrpSpPr>
+      <p:grpSpPr/>
+      <p:sp>
+        <p:nvSpPr>
+          <p:cNvPr id="10200" name="G_arc"/>
+          <p:cNvSpPr/>
+          <p:nvPr/>
+        </p:nvSpPr>
+        <p:spPr>
+          <a:xfrm>
+            <a:off x="228600" y="1371600"/>
+            <a:ext cx="1188720" cy="868680"/>
+          </a:xfrm>
+          <a:prstGeom prst="arc">
+            <a:avLst/>
+          </a:prstGeom>
+          <a:solidFill>
+            <a:srgbClr val="5B9BD5"/>
+          </a:solidFill>
+          <a:ln w="19050">
+            <a:solidFill>
+              <a:srgbClr val="1F3864"/>
+            </a:solidFill>
+          </a:ln>
+        </p:spPr>
+      </p:sp>
+      <p:sp>
+        <p:nvSpPr>
+          <p:cNvPr id="10201" name="G_cube"/>
+          <p:cNvSpPr/>
+          <p:nvPr/>
+        </p:nvSpPr>
+        <p:spPr>
+          <a:xfrm>
+            <a:off x="1676400" y="1371600"/>
+            <a:ext cx="1188720" cy="868680"/>
+          </a:xfrm>
+          <a:prstGeom prst="cube">
+            <a:avLst/>
+          </a:prstGeom>
+          <a:solidFill>
+            <a:srgbClr val="5B9BD5"/>
+          </a:solidFill>
+          <a:ln w="19050">
+            <a:solidFill>
+              <a:srgbClr val="1F3864"/>
+            </a:solidFill>
+          </a:ln>
+        </p:spPr>
+      </p:sp>
+      <p:sp>
+        <p:nvSpPr>
+          <p:cNvPr id="10202" name="G_chartPlus"/>
+          <p:cNvSpPr/>
+          <p:nvPr/>
+        </p:nvSpPr>
+        <p:spPr>
+          <a:xfrm>
+            <a:off x="3124200" y="1371600"/>
+            <a:ext cx="1188720" cy="868680"/>
+          </a:xfrm>
+          <a:prstGeom prst="chartPlus">
+            <a:avLst/>
+          </a:prstGeom>
+          <a:solidFill>
+            <a:srgbClr val="5B9BD5"/>
+          </a:solidFill>
+          <a:ln w="19050">
+            <a:solidFill>
+              <a:srgbClr val="1F3864"/>
+            </a:solidFill>
+          </a:ln>
+        </p:spPr>
+      </p:sp>
+      <p:sp>
+        <p:nvSpPr>
+          <p:cNvPr id="10203" name="G_bentConnector3"/>
+          <p:cNvSpPr/>
+          <p:nvPr/>
+        </p:nvSpPr>
+        <p:spPr>
+          <a:xfrm>
+            <a:off x="4572000" y="1371600"/>
+            <a:ext cx="1188720" cy="868680"/>
+          </a:xfrm>
+          <a:prstGeom prst="bentConnector3">
+            <a:avLst/>
+          </a:prstGeom>
+          <a:solidFill>
+            <a:srgbClr val="5B9BD5"/>
+          </a:solidFill>
+          <a:ln w="19050">
+            <a:solidFill>
+              <a:srgbClr val="1F3864"/>
+            </a:solidFill>
+          </a:ln>
+        </p:spPr>
+      </p:sp>
+      <p:sp>
+        <p:nvSpPr>
+          <p:cNvPr id="10204" name="G_actionButtonHome"/>
+          <p:cNvSpPr/>
+          <p:nvPr/>
+        </p:nvSpPr>
+        <p:spPr>
+          <a:xfrm>
+            <a:off x="6019800" y="1371600"/>
+            <a:ext cx="1188720" cy="868680"/>
+          </a:xfrm>
+          <a:prstGeom prst="actionButtonHome">
+            <a:avLst/>
+          </a:prstGeom>
+          <a:solidFill>
+            <a:srgbClr val="5B9BD5"/>
+          </a:solidFill>
+          <a:ln w="19050">
+            <a:solidFill>
+              <a:srgbClr val="1F3864"/>
+            </a:solidFill>
+          </a:ln>
+        </p:spPr>
+      </p:sp>
+      <p:sp>
+        <p:nvSpPr>
+          <p:cNvPr id="10205" name="G_star7"/>
+          <p:cNvSpPr/>
+          <p:nvPr/>
+        </p:nvSpPr>
+        <p:spPr>
+          <a:xfrm>
+            <a:off x="7467600" y="1371600"/>
+            <a:ext cx="1188720" cy="868680"/>
+          </a:xfrm>
+          <a:prstGeom prst="star7">
+            <a:avLst/>
+          </a:prstGeom>
+          <a:solidFill>
+            <a:srgbClr val="5B9BD5"/>
+          </a:solidFill>
+          <a:ln w="19050">
+            <a:solidFill>
+              <a:srgbClr val="1F3864"/>
+            </a:solidFill>
+          </a:ln>
         </p:spPr>
       </p:sp>
     </p:spTree>

</xml_diff>

<commit_message>
feat: per-path fill / stroke / coordinate space for a:custGeom
- parser keeps each a:path's fill mode, stroke="0" and its own w/h (when
  it differs from the first path's) as "F mode" / "S false" / "W pw ph"
  tokens in CustomGeomData.paths; single-path geometry is unchanged
- renderer draws custGeom through render_styled_paths like presets
  (stroke-only lines after fills, shade overlays); render_geom_paths
  removed
- serializer writes the tokens back as a:path attributes (rewritten as a
  pattern match over the compact tokens)
- fixture: slide 101 outline colour made visible on the dark background;
  slide 102 covers custGeom per-path styles + SVG→OOXML round-trip

Co-Authored-By: Claude Opus 5.5 <noreply@anthropic.com>
</commit_message>
<xml_diff>
--- a/test_fixtures/test_features.pptx
+++ b/test_fixtures/test_features.pptx
@@ -106,6 +106,7 @@
     <p:sldId id="354" r:id="rId107"/>
     <p:sldId id="355" r:id="rId108"/>
     <p:sldId id="356" r:id="rId109"/>
+    <p:sldId id="357" r:id="rId110"/>
   </p:sldIdLst>
   <p:sldSz cx="9144000" cy="6858000" type="screen4x3"/>
   <p:notesSz cx="6858000" cy="9144000"/>
@@ -8814,7 +8815,7 @@
           </a:solidFill>
           <a:ln w="19050">
             <a:solidFill>
-              <a:srgbClr val="1F3864"/>
+              <a:srgbClr val="FFC000"/>
             </a:solidFill>
           </a:ln>
         </p:spPr>
@@ -8838,7 +8839,7 @@
           </a:solidFill>
           <a:ln w="19050">
             <a:solidFill>
-              <a:srgbClr val="1F3864"/>
+              <a:srgbClr val="FFC000"/>
             </a:solidFill>
           </a:ln>
         </p:spPr>
@@ -8862,7 +8863,7 @@
           </a:solidFill>
           <a:ln w="19050">
             <a:solidFill>
-              <a:srgbClr val="1F3864"/>
+              <a:srgbClr val="FFC000"/>
             </a:solidFill>
           </a:ln>
         </p:spPr>
@@ -8886,7 +8887,7 @@
           </a:solidFill>
           <a:ln w="19050">
             <a:solidFill>
-              <a:srgbClr val="1F3864"/>
+              <a:srgbClr val="FFC000"/>
             </a:solidFill>
           </a:ln>
         </p:spPr>
@@ -8910,7 +8911,7 @@
           </a:solidFill>
           <a:ln w="19050">
             <a:solidFill>
-              <a:srgbClr val="1F3864"/>
+              <a:srgbClr val="FFC000"/>
             </a:solidFill>
           </a:ln>
         </p:spPr>
@@ -8934,7 +8935,91 @@
           </a:solidFill>
           <a:ln w="19050">
             <a:solidFill>
-              <a:srgbClr val="1F3864"/>
+              <a:srgbClr val="FFC000"/>
+            </a:solidFill>
+          </a:ln>
+        </p:spPr>
+      </p:sp>
+    </p:spTree>
+  </p:cSld>
+  <p:clrMapOvr>
+    <a:masterClrMapping/>
+  </p:clrMapOvr>
+</p:sld>
+</file>
+
+<file path=ppt/slides/slide102.xml><?xml version="1.0" encoding="utf-8"?>
+<p:sld xmlns:a="http://schemas.openxmlformats.org/drawingml/2006/main" xmlns:p="http://schemas.openxmlformats.org/presentationml/2006/main" xmlns:r="http://schemas.openxmlformats.org/officeDocument/2006/relationships">
+  <p:cSld>
+    <p:spTree>
+      <p:nvGrpSpPr>
+        <p:cNvPr id="1" name=""/>
+        <p:cNvGrpSpPr/>
+        <p:nvPr/>
+      </p:nvGrpSpPr>
+      <p:grpSpPr/>
+      <p:sp>
+        <p:nvSpPr>
+          <p:cNvPr id="10300" name="CustStyled"/>
+          <p:cNvSpPr/>
+          <p:nvPr/>
+        </p:nvSpPr>
+        <p:spPr>
+          <a:xfrm>
+            <a:off x="2286000" y="1371600"/>
+            <a:ext cx="2743200" cy="2743200"/>
+          </a:xfrm>
+          <a:custGeom>
+            <a:avLst/>
+            <a:gdLst/>
+            <a:rect l="l" t="t" r="r" b="b"/>
+            <a:pathLst>
+              <a:path w="100" h="100" stroke="0">
+                <a:moveTo>
+                  <a:pt x="0" y="0"/>
+                </a:moveTo>
+                <a:lnTo>
+                  <a:pt x="100" y="0"/>
+                </a:lnTo>
+                <a:lnTo>
+                  <a:pt x="100" y="100"/>
+                </a:lnTo>
+                <a:lnTo>
+                  <a:pt x="0" y="100"/>
+                </a:lnTo>
+                <a:close/>
+              </a:path>
+              <a:path w="50" h="50" fill="none">
+                <a:moveTo>
+                  <a:pt x="0" y="50"/>
+                </a:moveTo>
+                <a:lnTo>
+                  <a:pt x="50" y="0"/>
+                </a:lnTo>
+              </a:path>
+              <a:path w="100" h="100" fill="darken" stroke="0">
+                <a:moveTo>
+                  <a:pt x="25" y="25"/>
+                </a:moveTo>
+                <a:lnTo>
+                  <a:pt x="50" y="25"/>
+                </a:lnTo>
+                <a:lnTo>
+                  <a:pt x="50" y="50"/>
+                </a:lnTo>
+                <a:lnTo>
+                  <a:pt x="25" y="50"/>
+                </a:lnTo>
+                <a:close/>
+              </a:path>
+            </a:pathLst>
+          </a:custGeom>
+          <a:solidFill>
+            <a:srgbClr val="5B9BD5"/>
+          </a:solidFill>
+          <a:ln w="28575">
+            <a:solidFill>
+              <a:srgbClr val="FFC000"/>
             </a:solidFill>
           </a:ln>
         </p:spPr>

</xml_diff>

<commit_message>
fix: keep gradient / image / pattern slide backgrounds through the SVG round-trip
Only the solid background color (data-ooxml-bg) was written to and read
from the <svg> root, so updateSlideFromSvg dropped a slide's own gradient,
image or pattern background and the exported slide had none.

The shape fill attribute emit/parse code is now a set of prefix-aware
helpers (grad_fill_attrs / blip_fill_attrs / patt_fill_attrs and
parse_*_fill_attrs), used with "" for shapes, "bg-" for the slide
background on the <svg> root, and "t" for text runs (replacing the
separate tgrad/tpatt parsers). Shape and text output is unchanged.

The shared blip parser also accepts an SVG-only image (svg-rid without
rid), which the shape parser used to drop.

Fixture slides 103-105 carry their own gradient / pattern / image
backgrounds.

Co-Authored-By: Claude Opus 5.5 <noreply@anthropic.com>
</commit_message>
<xml_diff>
--- a/test_fixtures/test_features.pptx
+++ b/test_fixtures/test_features.pptx
@@ -107,6 +107,9 @@
     <p:sldId id="355" r:id="rId108"/>
     <p:sldId id="356" r:id="rId109"/>
     <p:sldId id="357" r:id="rId110"/>
+    <p:sldId id="358" r:id="rId111"/>
+    <p:sldId id="359" r:id="rId112"/>
+    <p:sldId id="360" r:id="rId113"/>
   </p:sldIdLst>
   <p:sldSz cx="9144000" cy="6858000" type="screen4x3"/>
   <p:notesSz cx="6858000" cy="9144000"/>
@@ -9024,6 +9027,101 @@
           </a:ln>
         </p:spPr>
       </p:sp>
+    </p:spTree>
+  </p:cSld>
+  <p:clrMapOvr>
+    <a:masterClrMapping/>
+  </p:clrMapOvr>
+</p:sld>
+</file>
+
+<file path=ppt/slides/slide103.xml><?xml version="1.0" encoding="utf-8"?>
+<p:sld xmlns:a="http://schemas.openxmlformats.org/drawingml/2006/main" xmlns:p="http://schemas.openxmlformats.org/presentationml/2006/main" xmlns:r="http://schemas.openxmlformats.org/officeDocument/2006/relationships">
+  <p:cSld>
+    <p:bg>
+      <p:bgPr>
+        <a:gradFill rotWithShape="1">
+          <a:gsLst>
+            <a:gs pos="0">
+              <a:srgbClr val="1F4E79"/>
+            </a:gs>
+            <a:gs pos="100000">
+              <a:srgbClr val="9DC3E6"/>
+            </a:gs>
+          </a:gsLst>
+          <a:lin ang="5400000" scaled="0"/>
+        </a:gradFill>
+        <a:effectLst/>
+      </p:bgPr>
+    </p:bg>
+    <p:spTree>
+      <p:nvGrpSpPr>
+        <p:cNvPr id="1" name=""/>
+        <p:cNvGrpSpPr/>
+        <p:nvPr/>
+      </p:nvGrpSpPr>
+      <p:grpSpPr/>
+    </p:spTree>
+  </p:cSld>
+  <p:clrMapOvr>
+    <a:masterClrMapping/>
+  </p:clrMapOvr>
+</p:sld>
+</file>
+
+<file path=ppt/slides/slide104.xml><?xml version="1.0" encoding="utf-8"?>
+<p:sld xmlns:a="http://schemas.openxmlformats.org/drawingml/2006/main" xmlns:p="http://schemas.openxmlformats.org/presentationml/2006/main" xmlns:r="http://schemas.openxmlformats.org/officeDocument/2006/relationships">
+  <p:cSld>
+    <p:bg>
+      <p:bgPr>
+        <a:pattFill prst="dkDnDiag">
+          <a:fgClr>
+            <a:srgbClr val="C00000"/>
+          </a:fgClr>
+          <a:bgClr>
+            <a:srgbClr val="FFF2CC"/>
+          </a:bgClr>
+        </a:pattFill>
+        <a:effectLst/>
+      </p:bgPr>
+    </p:bg>
+    <p:spTree>
+      <p:nvGrpSpPr>
+        <p:cNvPr id="1" name=""/>
+        <p:cNvGrpSpPr/>
+        <p:nvPr/>
+      </p:nvGrpSpPr>
+      <p:grpSpPr/>
+    </p:spTree>
+  </p:cSld>
+  <p:clrMapOvr>
+    <a:masterClrMapping/>
+  </p:clrMapOvr>
+</p:sld>
+</file>
+
+<file path=ppt/slides/slide105.xml><?xml version="1.0" encoding="utf-8"?>
+<p:sld xmlns:a="http://schemas.openxmlformats.org/drawingml/2006/main" xmlns:p="http://schemas.openxmlformats.org/presentationml/2006/main" xmlns:r="http://schemas.openxmlformats.org/officeDocument/2006/relationships">
+  <p:cSld>
+    <p:bg>
+      <p:bgPr>
+        <a:blipFill dpi="0" rotWithShape="1">
+          <a:blip r:embed="rId2"/>
+          <a:srcRect/>
+          <a:stretch>
+            <a:fillRect/>
+          </a:stretch>
+        </a:blipFill>
+        <a:effectLst/>
+      </p:bgPr>
+    </p:bg>
+    <p:spTree>
+      <p:nvGrpSpPr>
+        <p:cNvPr id="1" name=""/>
+        <p:cNvGrpSpPr/>
+        <p:nvPr/>
+      </p:nvGrpSpPr>
+      <p:grpSpPr/>
     </p:spTree>
   </p:cSld>
   <p:clrMapOvr>

</xml_diff>

<commit_message>
feat: alt text, and keep shape ids / names on export
The serializer wrote <p:cNvPr id="0" name=""/> for every shape, so an
edited slide lost its shape names, its animations' spid targets and its
connector endpoints (all shapes shared id 0); picture hyperlinks were
dropped too.

- Shape gains nv_id / nv_name / nv_descr / nv_title, parsed from p:cNvPr,
  round-tripped as data-ooxml-nv-*, and written back with hyperlinks.
- Ids stay unique: added, duplicated and pasted shapes get fresh ids
  (with_fresh_nv_ids), and serialize_slide renumbers any remaining
  duplicate (first use wins, so animation targets survive).
- Alt text (descr, else title) renders as an SVG <title> on the shape's
  <g>: its accessible name and tooltip.
- Fixture slide 106 (alt text + an animation targeting a shape by id).
- TODO.md: alt text done; stale E2/E3/E4/E5/X1 statuses corrected.

Co-Authored-By: Claude Opus 5.5 <noreply@anthropic.com>
</commit_message>
<xml_diff>
--- a/test_fixtures/test_features.pptx
+++ b/test_fixtures/test_features.pptx
@@ -110,6 +110,7 @@
     <p:sldId id="358" r:id="rId111"/>
     <p:sldId id="359" r:id="rId112"/>
     <p:sldId id="360" r:id="rId113"/>
+    <p:sldId id="361" r:id="rId114"/>
   </p:sldIdLst>
   <p:sldSz cx="9144000" cy="6858000" type="screen4x3"/>
   <p:notesSz cx="6858000" cy="9144000"/>
@@ -9127,6 +9128,148 @@
   <p:clrMapOvr>
     <a:masterClrMapping/>
   </p:clrMapOvr>
+</p:sld>
+</file>
+
+<file path=ppt/slides/slide106.xml><?xml version="1.0" encoding="utf-8"?>
+<p:sld xmlns:a="http://schemas.openxmlformats.org/drawingml/2006/main" xmlns:p="http://schemas.openxmlformats.org/presentationml/2006/main" xmlns:r="http://schemas.openxmlformats.org/officeDocument/2006/relationships">
+  <p:cSld>
+    <p:spTree>
+      <p:nvGrpSpPr>
+        <p:cNvPr id="1" name=""/>
+        <p:cNvGrpSpPr/>
+        <p:nvPr/>
+      </p:nvGrpSpPr>
+      <p:grpSpPr/>
+      <p:sp>
+        <p:nvSpPr>
+          <p:cNvPr id="2" name="Revenue Box" descr="Quarterly revenue, up 12% &amp; rising" title="Revenue"/>
+          <p:cNvSpPr/>
+          <p:nvPr/>
+        </p:nvSpPr>
+        <p:spPr>
+          <a:xfrm>
+            <a:off x="914400" y="914400"/>
+            <a:ext cx="2743200" cy="1371600"/>
+          </a:xfrm>
+          <a:prstGeom prst="rect">
+            <a:avLst/>
+          </a:prstGeom>
+        </p:spPr>
+        <p:style>
+          <a:lnRef idx="1">
+            <a:schemeClr val="accent1"/>
+          </a:lnRef>
+          <a:fillRef idx="3">
+            <a:schemeClr val="accent1"/>
+          </a:fillRef>
+          <a:effectRef idx="2">
+            <a:schemeClr val="accent1"/>
+          </a:effectRef>
+          <a:fontRef idx="minor">
+            <a:schemeClr val="lt1"/>
+          </a:fontRef>
+        </p:style>
+        <p:txBody>
+          <a:bodyPr rtlCol="0" anchor="ctr"/>
+          <a:lstStyle/>
+          <a:p>
+            <a:r>
+              <a:t>Revenue</a:t>
+            </a:r>
+          </a:p>
+        </p:txBody>
+      </p:sp>
+      <p:pic>
+        <p:nvPicPr>
+          <p:cNvPr id="3" name="Logo" descr="Company logo"/>
+          <p:cNvPicPr>
+            <a:picLocks noChangeAspect="1"/>
+          </p:cNvPicPr>
+          <p:nvPr/>
+        </p:nvPicPr>
+        <p:blipFill>
+          <a:blip r:embed="rId2"/>
+          <a:stretch>
+            <a:fillRect/>
+          </a:stretch>
+        </p:blipFill>
+        <p:spPr>
+          <a:xfrm>
+            <a:off x="4572000" y="914400"/>
+            <a:ext cx="1828800" cy="1828800"/>
+          </a:xfrm>
+          <a:prstGeom prst="rect">
+            <a:avLst/>
+          </a:prstGeom>
+        </p:spPr>
+      </p:pic>
+    </p:spTree>
+  </p:cSld>
+  <p:clrMapOvr>
+    <a:masterClrMapping/>
+  </p:clrMapOvr>
+  <p:timing>
+    <p:tnLst>
+      <p:par>
+        <p:cTn id="1" dur="indefinite" restart="never" nodeType="tmRoot">
+          <p:childTnLst>
+            <p:seq concurrent="1" nextAc="seek">
+              <p:cTn id="2" dur="indefinite" nodeType="mainSeq">
+                <p:childTnLst>
+                  <p:par>
+                    <p:cTn id="3" fill="hold">
+                      <p:stCondLst>
+                        <p:cond delay="indefinite"/>
+                      </p:stCondLst>
+                      <p:childTnLst>
+                        <p:par>
+                          <p:cTn id="4" fill="hold">
+                            <p:stCondLst>
+                              <p:cond delay="0"/>
+                            </p:stCondLst>
+                            <p:childTnLst>
+                              <p:par>
+                                <p:cTn id="5" presetID="1" presetClass="entr" presetSubtype="0" fill="hold" nodeType="clickEffect">
+                                  <p:stCondLst>
+                                    <p:cond delay="0"/>
+                                  </p:stCondLst>
+                                  <p:childTnLst>
+                                    <p:set>
+                                      <p:cBhvr>
+                                        <p:cTn id="6" dur="1" fill="hold">
+                                          <p:stCondLst>
+                                            <p:cond delay="0"/>
+                                          </p:stCondLst>
+                                        </p:cTn>
+                                        <p:tgtEl>
+                                          <p:spTgt spid="2"/>
+                                        </p:tgtEl>
+                                        <p:attrNameLst>
+                                          <p:attrName>style.visibility</p:attrName>
+                                        </p:attrNameLst>
+                                      </p:cBhvr>
+                                      <p:to>
+                                        <p:strVal val="visible"/>
+                                      </p:to>
+                                    </p:set>
+                                  </p:childTnLst>
+                                </p:cTn>
+                              </p:par>
+                            </p:childTnLst>
+                          </p:cTn>
+                        </p:par>
+                      </p:childTnLst>
+                    </p:cTn>
+                  </p:par>
+                </p:childTnLst>
+              </p:cTn>
+            </p:seq>
+          </p:childTnLst>
+        </p:cTn>
+      </p:par>
+    </p:tnLst>
+  </p:timing>
 </p:sld>
 </file>
 

</xml_diff>

<commit_message>
fix: don't draw hidden shapes (p:cNvPr hidden="1")
Shapes hidden in PowerPoint's Selection Pane rendered like any other.
Shape.nv_hidden is parsed from p:cNvPr; the shape's <g> gets
display="none" (no reflection either) so it stays in the SVG for the
round-trip, data-ooxml-nv-hidden carries the flag, and the serializer
writes hidden="1" back. Fixture slide 107.

Co-Authored-By: Claude Opus 5.5 <noreply@anthropic.com>
</commit_message>
<xml_diff>
--- a/test_fixtures/test_features.pptx
+++ b/test_fixtures/test_features.pptx
@@ -111,6 +111,7 @@
     <p:sldId id="359" r:id="rId112"/>
     <p:sldId id="360" r:id="rId113"/>
     <p:sldId id="361" r:id="rId114"/>
+    <p:sldId id="362" r:id="rId115"/>
   </p:sldIdLst>
   <p:sldSz cx="9144000" cy="6858000" type="screen4x3"/>
   <p:notesSz cx="6858000" cy="9144000"/>
@@ -9270,6 +9271,102 @@
       </p:par>
     </p:tnLst>
   </p:timing>
+</p:sld>
+</file>
+
+<file path=ppt/slides/slide107.xml><?xml version="1.0" encoding="utf-8"?>
+<p:sld xmlns:a="http://schemas.openxmlformats.org/drawingml/2006/main" xmlns:p="http://schemas.openxmlformats.org/presentationml/2006/main" xmlns:r="http://schemas.openxmlformats.org/officeDocument/2006/relationships">
+  <p:cSld>
+    <p:spTree>
+      <p:nvGrpSpPr>
+        <p:cNvPr id="1" name=""/>
+        <p:cNvGrpSpPr/>
+        <p:nvPr/>
+      </p:nvGrpSpPr>
+      <p:grpSpPr/>
+      <p:sp>
+        <p:nvSpPr>
+          <p:cNvPr id="2" name="Shown"/>
+          <p:cNvSpPr/>
+          <p:nvPr/>
+        </p:nvSpPr>
+        <p:spPr>
+          <a:xfrm>
+            <a:off x="914400" y="914400"/>
+            <a:ext cx="2743200" cy="1371600"/>
+          </a:xfrm>
+          <a:prstGeom prst="rect">
+            <a:avLst/>
+          </a:prstGeom>
+        </p:spPr>
+        <p:style>
+          <a:lnRef idx="1">
+            <a:schemeClr val="accent1"/>
+          </a:lnRef>
+          <a:fillRef idx="3">
+            <a:schemeClr val="accent1"/>
+          </a:fillRef>
+          <a:effectRef idx="2">
+            <a:schemeClr val="accent1"/>
+          </a:effectRef>
+          <a:fontRef idx="minor">
+            <a:schemeClr val="lt1"/>
+          </a:fontRef>
+        </p:style>
+        <p:txBody>
+          <a:bodyPr rtlCol="0" anchor="ctr"/>
+          <a:lstStyle/>
+          <a:p>
+            <a:r>
+              <a:t>Visible</a:t>
+            </a:r>
+          </a:p>
+        </p:txBody>
+      </p:sp>
+      <p:sp>
+        <p:nvSpPr>
+          <p:cNvPr id="3" name="Hidden" hidden="1"/>
+          <p:cNvSpPr/>
+          <p:nvPr/>
+        </p:nvSpPr>
+        <p:spPr>
+          <a:xfrm>
+            <a:off x="4572000" y="914400"/>
+            <a:ext cx="2743200" cy="1371600"/>
+          </a:xfrm>
+          <a:prstGeom prst="rect">
+            <a:avLst/>
+          </a:prstGeom>
+        </p:spPr>
+        <p:style>
+          <a:lnRef idx="1">
+            <a:schemeClr val="accent1"/>
+          </a:lnRef>
+          <a:fillRef idx="3">
+            <a:schemeClr val="accent1"/>
+          </a:fillRef>
+          <a:effectRef idx="2">
+            <a:schemeClr val="accent1"/>
+          </a:effectRef>
+          <a:fontRef idx="minor">
+            <a:schemeClr val="lt1"/>
+          </a:fontRef>
+        </p:style>
+        <p:txBody>
+          <a:bodyPr rtlCol="0" anchor="ctr"/>
+          <a:lstStyle/>
+          <a:p>
+            <a:r>
+              <a:t>Hidden text</a:t>
+            </a:r>
+          </a:p>
+        </p:txBody>
+      </p:sp>
+    </p:spTree>
+  </p:cSld>
+  <p:clrMapOvr>
+    <a:masterClrMapping/>
+  </p:clrMapOvr>
 </p:sld>
 </file>
 

</xml_diff>